<commit_message>
docs: correct data provenance to reflect self-generated synthetic clinical records
</commit_message>
<xml_diff>
--- a/docs/AXIOM_D04_Deck.pptx
+++ b/docs/AXIOM_D04_Deck.pptx
@@ -3445,7 +3445,7 @@
                 </a:solidFill>
                 <a:latin typeface="Calibri"/>
               </a:rPr>
-              <a:t>All clinical data is synthetic, </a:t>
+              <a:t>All clinical data is self-generated. </a:t>
             </a:r>
             <a:r>
               <a:rPr sz="1300">
@@ -3454,7 +3454,7 @@
                 </a:solidFill>
                 <a:latin typeface="Calibri"/>
               </a:rPr>
-              <a:t>generated from Synthea's physiological model. Real disease trajectories, no real patients.</a:t>
+              <a:t>We wrote both the records and the answer key; recall measures our pipeline against our own assumptions.</a:t>
             </a:r>
           </a:p>
           <a:p>

</xml_diff>